<commit_message>
add w12s1_num.md in 1960
</commit_message>
<xml_diff>
--- a/26fall/1860/Lecture/Week1.2/Lecture 1.2.1.pptx
+++ b/26fall/1860/Lecture/Week1.2/Lecture 1.2.1.pptx
@@ -423,7 +423,7 @@
           <a:p>
             <a:fld id="{7AF13AE8-A0E4-4F1F-9580-770EB244677C}" type="datetimeFigureOut">
               <a:rPr lang="en-GB" smtClean="0"/>
-              <a:t>23/03/2026</a:t>
+              <a:t>05/10/2026</a:t>
             </a:fld>
             <a:endParaRPr lang="en-GB"/>
           </a:p>
@@ -924,7 +924,7 @@
           <a:p>
             <a:fld id="{E2426109-4B64-467B-8757-ABD07F902EB6}" type="datetimeFigureOut">
               <a:rPr lang="en-GB" smtClean="0"/>
-              <a:t>23/03/2026</a:t>
+              <a:t>05/10/2026</a:t>
             </a:fld>
             <a:endParaRPr lang="en-GB"/>
           </a:p>
@@ -1124,7 +1124,7 @@
           <a:p>
             <a:fld id="{E2426109-4B64-467B-8757-ABD07F902EB6}" type="datetimeFigureOut">
               <a:rPr lang="en-GB" smtClean="0"/>
-              <a:t>23/03/2026</a:t>
+              <a:t>05/10/2026</a:t>
             </a:fld>
             <a:endParaRPr lang="en-GB"/>
           </a:p>
@@ -1334,7 +1334,7 @@
           <a:p>
             <a:fld id="{E2426109-4B64-467B-8757-ABD07F902EB6}" type="datetimeFigureOut">
               <a:rPr lang="en-GB" smtClean="0"/>
-              <a:t>23/03/2026</a:t>
+              <a:t>05/10/2026</a:t>
             </a:fld>
             <a:endParaRPr lang="en-GB"/>
           </a:p>
@@ -1534,7 +1534,7 @@
           <a:p>
             <a:fld id="{E2426109-4B64-467B-8757-ABD07F902EB6}" type="datetimeFigureOut">
               <a:rPr lang="en-GB" smtClean="0"/>
-              <a:t>23/03/2026</a:t>
+              <a:t>05/10/2026</a:t>
             </a:fld>
             <a:endParaRPr lang="en-GB"/>
           </a:p>
@@ -1810,7 +1810,7 @@
           <a:p>
             <a:fld id="{E2426109-4B64-467B-8757-ABD07F902EB6}" type="datetimeFigureOut">
               <a:rPr lang="en-GB" smtClean="0"/>
-              <a:t>23/03/2026</a:t>
+              <a:t>05/10/2026</a:t>
             </a:fld>
             <a:endParaRPr lang="en-GB"/>
           </a:p>
@@ -2078,7 +2078,7 @@
           <a:p>
             <a:fld id="{E2426109-4B64-467B-8757-ABD07F902EB6}" type="datetimeFigureOut">
               <a:rPr lang="en-GB" smtClean="0"/>
-              <a:t>23/03/2026</a:t>
+              <a:t>05/10/2026</a:t>
             </a:fld>
             <a:endParaRPr lang="en-GB"/>
           </a:p>
@@ -2493,7 +2493,7 @@
           <a:p>
             <a:fld id="{E2426109-4B64-467B-8757-ABD07F902EB6}" type="datetimeFigureOut">
               <a:rPr lang="en-GB" smtClean="0"/>
-              <a:t>23/03/2026</a:t>
+              <a:t>05/10/2026</a:t>
             </a:fld>
             <a:endParaRPr lang="en-GB"/>
           </a:p>
@@ -2635,7 +2635,7 @@
           <a:p>
             <a:fld id="{E2426109-4B64-467B-8757-ABD07F902EB6}" type="datetimeFigureOut">
               <a:rPr lang="en-GB" smtClean="0"/>
-              <a:t>23/03/2026</a:t>
+              <a:t>05/10/2026</a:t>
             </a:fld>
             <a:endParaRPr lang="en-GB"/>
           </a:p>
@@ -2748,7 +2748,7 @@
           <a:p>
             <a:fld id="{E2426109-4B64-467B-8757-ABD07F902EB6}" type="datetimeFigureOut">
               <a:rPr lang="en-GB" smtClean="0"/>
-              <a:t>23/03/2026</a:t>
+              <a:t>05/10/2026</a:t>
             </a:fld>
             <a:endParaRPr lang="en-GB"/>
           </a:p>
@@ -3061,7 +3061,7 @@
           <a:p>
             <a:fld id="{E2426109-4B64-467B-8757-ABD07F902EB6}" type="datetimeFigureOut">
               <a:rPr lang="en-GB" smtClean="0"/>
-              <a:t>23/03/2026</a:t>
+              <a:t>05/10/2026</a:t>
             </a:fld>
             <a:endParaRPr lang="en-GB"/>
           </a:p>
@@ -3350,7 +3350,7 @@
           <a:p>
             <a:fld id="{E2426109-4B64-467B-8757-ABD07F902EB6}" type="datetimeFigureOut">
               <a:rPr lang="en-GB" smtClean="0"/>
-              <a:t>23/03/2026</a:t>
+              <a:t>05/10/2026</a:t>
             </a:fld>
             <a:endParaRPr lang="en-GB"/>
           </a:p>
@@ -3602,7 +3602,7 @@
           <a:p>
             <a:fld id="{E2426109-4B64-467B-8757-ABD07F902EB6}" type="datetimeFigureOut">
               <a:rPr lang="en-GB" smtClean="0"/>
-              <a:t>23/03/2026</a:t>
+              <a:t>05/10/2026</a:t>
             </a:fld>
             <a:endParaRPr lang="en-GB"/>
           </a:p>
@@ -15215,6 +15215,88 @@
           </p:graphicFrame>
         </mc:Fallback>
       </mc:AlternateContent>
+      <p:sp>
+        <p:nvSpPr>
+          <p:cNvPr id="6" name="矩形 5">
+            <a:extLst>
+              <a:ext uri="{FF2B5EF4-FFF2-40B4-BE49-F238E27FC236}">
+                <a16:creationId xmlns:a16="http://schemas.microsoft.com/office/drawing/2014/main" id="{F7543F02-245E-E829-758C-2467A9625E07}"/>
+              </a:ext>
+            </a:extLst>
+          </p:cNvPr>
+          <p:cNvSpPr/>
+          <p:nvPr/>
+        </p:nvSpPr>
+        <p:spPr>
+          <a:xfrm>
+            <a:off x="2618913" y="3783791"/>
+            <a:ext cx="2281561" cy="406469"/>
+          </a:xfrm>
+          <a:prstGeom prst="rect">
+            <a:avLst/>
+          </a:prstGeom>
+          <a:noFill/>
+        </p:spPr>
+        <p:style>
+          <a:lnRef idx="2">
+            <a:schemeClr val="accent1">
+              <a:shade val="15000"/>
+            </a:schemeClr>
+          </a:lnRef>
+          <a:fillRef idx="1">
+            <a:schemeClr val="accent1"/>
+          </a:fillRef>
+          <a:effectRef idx="0">
+            <a:schemeClr val="accent1"/>
+          </a:effectRef>
+          <a:fontRef idx="minor">
+            <a:schemeClr val="lt1"/>
+          </a:fontRef>
+        </p:style>
+        <p:txBody>
+          <a:bodyPr rtlCol="0" anchor="ctr"/>
+          <a:lstStyle/>
+          <a:p>
+            <a:pPr algn="ctr"/>
+            <a:endParaRPr lang="zh-CN" altLang="en-US"/>
+          </a:p>
+        </p:txBody>
+      </p:sp>
+      <p:sp>
+        <p:nvSpPr>
+          <p:cNvPr id="7" name="文本框 6">
+            <a:extLst>
+              <a:ext uri="{FF2B5EF4-FFF2-40B4-BE49-F238E27FC236}">
+                <a16:creationId xmlns:a16="http://schemas.microsoft.com/office/drawing/2014/main" id="{C336E414-FF8C-4C23-3C1C-F21DA9A6D170}"/>
+              </a:ext>
+            </a:extLst>
+          </p:cNvPr>
+          <p:cNvSpPr txBox="1"/>
+          <p:nvPr/>
+        </p:nvSpPr>
+        <p:spPr>
+          <a:xfrm>
+            <a:off x="5046331" y="3820928"/>
+            <a:ext cx="646331" cy="369332"/>
+          </a:xfrm>
+          <a:prstGeom prst="rect">
+            <a:avLst/>
+          </a:prstGeom>
+          <a:noFill/>
+        </p:spPr>
+        <p:txBody>
+          <a:bodyPr wrap="none" rtlCol="0">
+            <a:spAutoFit/>
+          </a:bodyPr>
+          <a:lstStyle/>
+          <a:p>
+            <a:r>
+              <a:rPr lang="zh-CN" altLang="en-US" dirty="0"/>
+              <a:t>进位</a:t>
+            </a:r>
+          </a:p>
+        </p:txBody>
+      </p:sp>
     </p:spTree>
     <p:extLst>
       <p:ext uri="{BB962C8B-B14F-4D97-AF65-F5344CB8AC3E}">
@@ -15617,7 +15699,11 @@
           <a:lstStyle/>
           <a:p>
             <a:r>
-              <a:rPr lang="en-GB" dirty="0"/>
+              <a:rPr lang="en-GB" dirty="0">
+                <a:solidFill>
+                  <a:srgbClr val="FF0000"/>
+                </a:solidFill>
+              </a:rPr>
               <a:t>Converting decimal to binary</a:t>
             </a:r>
           </a:p>
@@ -17234,7 +17320,15 @@
           <a:p>
             <a:r>
               <a:rPr lang="en-GB" dirty="0"/>
-              <a:t>Example: converting decimal to binary</a:t>
+              <a:t>Example</a:t>
+            </a:r>
+            <a:r>
+              <a:rPr lang="en-GB" dirty="0">
+                <a:solidFill>
+                  <a:srgbClr val="FF0000"/>
+                </a:solidFill>
+              </a:rPr>
+              <a:t>: converting decimal to binary</a:t>
             </a:r>
           </a:p>
         </p:txBody>
@@ -17331,8 +17425,16 @@
           </a:p>
           <a:p>
             <a:r>
+              <a:rPr lang="en-GB" dirty="0">
+                <a:solidFill>
+                  <a:srgbClr val="FF0000"/>
+                </a:solidFill>
+              </a:rPr>
+              <a:t>Put these in reverse order </a:t>
+            </a:r>
+            <a:r>
               <a:rPr lang="en-GB" dirty="0"/>
-              <a:t>Put these in reverse order (because we go right to left) to get 101010</a:t>
+              <a:t>(because we go right to left) to get 101010</a:t>
             </a:r>
             <a:r>
               <a:rPr lang="en-GB" baseline="-25000" dirty="0"/>
@@ -19002,7 +19104,11 @@
           <a:lstStyle/>
           <a:p>
             <a:r>
-              <a:rPr lang="en-GB" dirty="0"/>
+              <a:rPr lang="en-GB" dirty="0">
+                <a:solidFill>
+                  <a:srgbClr val="FF0000"/>
+                </a:solidFill>
+              </a:rPr>
               <a:t>Converting decimal to hexadecimal</a:t>
             </a:r>
           </a:p>
@@ -19443,8 +19549,16 @@
           </a:p>
           <a:p>
             <a:r>
+              <a:rPr lang="en-GB" dirty="0">
+                <a:solidFill>
+                  <a:srgbClr val="FF0000"/>
+                </a:solidFill>
+              </a:rPr>
+              <a:t>Reverse order</a:t>
+            </a:r>
+            <a:r>
               <a:rPr lang="en-GB" dirty="0"/>
-              <a:t>Reverse order to get 1F67.</a:t>
+              <a:t> to get 1F67.</a:t>
             </a:r>
           </a:p>
         </p:txBody>
@@ -19595,7 +19709,11 @@
           <a:lstStyle/>
           <a:p>
             <a:r>
-              <a:rPr lang="en-GB" dirty="0"/>
+              <a:rPr lang="en-GB" dirty="0">
+                <a:solidFill>
+                  <a:srgbClr val="FF0000"/>
+                </a:solidFill>
+              </a:rPr>
               <a:t>Converting hexadecimal to binary</a:t>
             </a:r>
           </a:p>
@@ -19651,13 +19769,29 @@
           <a:p>
             <a:r>
               <a:rPr lang="en-GB" dirty="0"/>
-              <a:t>Hex to binary: Convert each hex digit to 4-bit binary and concatenate (from left to right)</a:t>
+              <a:t>Hex to binary: </a:t>
+            </a:r>
+            <a:r>
+              <a:rPr lang="en-GB" dirty="0">
+                <a:solidFill>
+                  <a:srgbClr val="FF0000"/>
+                </a:solidFill>
+              </a:rPr>
+              <a:t>Convert each hex digit to 4-bit binary and concatenate (from left to right)</a:t>
             </a:r>
           </a:p>
           <a:p>
             <a:r>
               <a:rPr lang="en-GB" dirty="0"/>
-              <a:t>Binary to hex: Split binary into groups of 4 bits (from right) and convert each group of 4 bits to a hex digit</a:t>
+              <a:t>Binary to hex: </a:t>
+            </a:r>
+            <a:r>
+              <a:rPr lang="en-GB" dirty="0">
+                <a:solidFill>
+                  <a:srgbClr val="FF0000"/>
+                </a:solidFill>
+              </a:rPr>
+              <a:t>Split binary into groups of 4 bits (from right) and convert each group of 4 bits to a hex digit</a:t>
             </a:r>
           </a:p>
         </p:txBody>
@@ -20200,6 +20334,11 @@
               <a:rPr lang="en-GB" dirty="0"/>
               <a:t>Binary Fractions: Radix Point</a:t>
             </a:r>
+            <a:r>
+              <a:rPr lang="zh-CN" altLang="en-US" dirty="0"/>
+              <a:t>（小数点）</a:t>
+            </a:r>
+            <a:endParaRPr lang="en-GB" dirty="0"/>
           </a:p>
         </p:txBody>
       </p:sp>
@@ -20455,7 +20594,11 @@
           <a:lstStyle/>
           <a:p>
             <a:r>
-              <a:rPr lang="en-GB" dirty="0"/>
+              <a:rPr lang="en-GB" dirty="0">
+                <a:solidFill>
+                  <a:srgbClr val="FF0000"/>
+                </a:solidFill>
+              </a:rPr>
               <a:t>Binary Fractions</a:t>
             </a:r>
           </a:p>

</xml_diff>